<commit_message>
pitch: fix sovrapposizioni + logo + chiusura pulita
- Slide 11: evidence bar fix overflow "5.600", fonti non troncate
- Slide 15: pricing font ridotto (36→28pt), no sovrapposizione
- Slide 17: chiusura solo testo (no logo su dark), spacing corretto
- Slide 9/14: rimosso logo watermark dove sovrappone callout
- Slide 2-16: logo watermark proporzionato (0.55"×0.50")
- Slide 1: logo hero proporzionato (1.6"×1.46", ratio 1.094:1)
- Asset: pitch-logo.png + pitch-icon.png

Co-Authored-By: Claude Opus 4.6 (1M context) <noreply@anthropic.com>
</commit_message>
<xml_diff>
--- a/data/FitManager_Pitch_Deck_v10.pptx
+++ b/data/FitManager_Pitch_Deck_v10.pptx
@@ -2319,16 +2319,40 @@
           <a:ln/>
         </p:spPr>
       </p:sp>
-      <p:sp>
-        <p:nvSpPr>
-          <p:cNvPr id="3" name="Text 1"/>
-          <p:cNvSpPr/>
-          <p:nvPr/>
-        </p:nvSpPr>
-        <p:spPr>
-          <a:xfrm>
-            <a:off x="731520" y="914400"/>
-            <a:ext cx="7680960" cy="914400"/>
+      <p:pic>
+        <p:nvPicPr>
+          <p:cNvPr id="3" name="Image 0" descr="C:/Users/gvera/Projects/FitManager_AI_Studio/data/pitch-logo.png">    </p:cNvPr>
+          <p:cNvPicPr>
+            <a:picLocks noChangeAspect="1"/>
+          </p:cNvPicPr>
+          <p:nvPr/>
+        </p:nvPicPr>
+        <p:blipFill>
+          <a:blip r:embed="rId1"/>
+          <a:stretch>
+            <a:fillRect/>
+          </a:stretch>
+        </p:blipFill>
+        <p:spPr>
+          <a:xfrm>
+            <a:off x="731520" y="320040"/>
+            <a:ext cx="1463040" cy="1335024"/>
+          </a:xfrm>
+          <a:prstGeom prst="rect">
+            <a:avLst/>
+          </a:prstGeom>
+        </p:spPr>
+      </p:pic>
+      <p:sp>
+        <p:nvSpPr>
+          <p:cNvPr id="4" name="Text 1"/>
+          <p:cNvSpPr/>
+          <p:nvPr/>
+        </p:nvSpPr>
+        <p:spPr>
+          <a:xfrm>
+            <a:off x="2377440" y="411480"/>
+            <a:ext cx="6217920" cy="640080"/>
           </a:xfrm>
           <a:prstGeom prst="rect">
             <a:avLst/>
@@ -2344,7 +2368,7 @@
               <a:buNone/>
             </a:pPr>
             <a:r>
-              <a:rPr lang="en-US" sz="4800" b="1" dirty="0">
+              <a:rPr lang="en-US" sz="4200" b="1" dirty="0">
                 <a:solidFill>
                   <a:srgbClr val="FFFFFF"/>
                 </a:solidFill>
@@ -2354,13 +2378,52 @@
               </a:rPr>
               <a:t>FitManager Studio+</a:t>
             </a:r>
-            <a:endParaRPr lang="en-US" sz="4800" dirty="0"/>
-          </a:p>
-        </p:txBody>
-      </p:sp>
-      <p:sp>
-        <p:nvSpPr>
-          <p:cNvPr id="4" name="Text 2"/>
+            <a:endParaRPr lang="en-US" sz="4200" dirty="0"/>
+          </a:p>
+        </p:txBody>
+      </p:sp>
+      <p:sp>
+        <p:nvSpPr>
+          <p:cNvPr id="5" name="Text 2"/>
+          <p:cNvSpPr/>
+          <p:nvPr/>
+        </p:nvSpPr>
+        <p:spPr>
+          <a:xfrm>
+            <a:off x="2377440" y="1005840"/>
+            <a:ext cx="6217920" cy="320040"/>
+          </a:xfrm>
+          <a:prstGeom prst="rect">
+            <a:avLst/>
+          </a:prstGeom>
+          <a:noFill/>
+          <a:ln/>
+        </p:spPr>
+        <p:txBody>
+          <a:bodyPr wrap="square" rtlCol="0" anchor="ctr"/>
+          <a:lstStyle/>
+          <a:p>
+            <a:pPr indent="0" marL="0">
+              <a:buNone/>
+            </a:pPr>
+            <a:r>
+              <a:rPr lang="en-US" sz="1400" i="1" dirty="0">
+                <a:solidFill>
+                  <a:srgbClr val="64748B"/>
+                </a:solidFill>
+                <a:latin typeface="Calibri" pitchFamily="34" charset="0"/>
+                <a:ea typeface="Calibri" pitchFamily="34" charset="-122"/>
+                <a:cs typeface="Calibri" pitchFamily="34" charset="-120"/>
+              </a:rPr>
+              <a:t>Kinesiologist Workflow Platform</a:t>
+            </a:r>
+            <a:endParaRPr lang="en-US" sz="1400" dirty="0"/>
+          </a:p>
+        </p:txBody>
+      </p:sp>
+      <p:sp>
+        <p:nvSpPr>
+          <p:cNvPr id="6" name="Text 3"/>
           <p:cNvSpPr/>
           <p:nvPr/>
         </p:nvSpPr>
@@ -2422,7 +2485,7 @@
       </p:sp>
       <p:sp>
         <p:nvSpPr>
-          <p:cNvPr id="5" name="Text 3"/>
+          <p:cNvPr id="7" name="Text 4"/>
           <p:cNvSpPr/>
           <p:nvPr/>
         </p:nvSpPr>
@@ -2461,7 +2524,7 @@
       </p:sp>
       <p:sp>
         <p:nvSpPr>
-          <p:cNvPr id="6" name="Shape 4"/>
+          <p:cNvPr id="8" name="Shape 5"/>
           <p:cNvSpPr/>
           <p:nvPr/>
         </p:nvSpPr>
@@ -2481,7 +2544,7 @@
       </p:sp>
       <p:sp>
         <p:nvSpPr>
-          <p:cNvPr id="7" name="Text 5"/>
+          <p:cNvPr id="9" name="Text 6"/>
           <p:cNvSpPr/>
           <p:nvPr/>
         </p:nvSpPr>
@@ -2520,7 +2583,7 @@
       </p:sp>
       <p:sp>
         <p:nvSpPr>
-          <p:cNvPr id="8" name="Text 6"/>
+          <p:cNvPr id="10" name="Text 7"/>
           <p:cNvSpPr/>
           <p:nvPr/>
         </p:nvSpPr>
@@ -2576,7 +2639,7 @@
       </p:sp>
       <p:sp>
         <p:nvSpPr>
-          <p:cNvPr id="9" name="Text 7"/>
+          <p:cNvPr id="11" name="Text 8"/>
           <p:cNvSpPr/>
           <p:nvPr/>
         </p:nvSpPr>
@@ -2615,7 +2678,7 @@
       </p:sp>
       <p:sp>
         <p:nvSpPr>
-          <p:cNvPr id="10" name="Text 8"/>
+          <p:cNvPr id="12" name="Text 9"/>
           <p:cNvSpPr/>
           <p:nvPr/>
         </p:nvSpPr>
@@ -2671,7 +2734,7 @@
       </p:sp>
       <p:sp>
         <p:nvSpPr>
-          <p:cNvPr id="11" name="Text 9"/>
+          <p:cNvPr id="13" name="Text 10"/>
           <p:cNvSpPr/>
           <p:nvPr/>
         </p:nvSpPr>
@@ -2710,7 +2773,7 @@
       </p:sp>
       <p:sp>
         <p:nvSpPr>
-          <p:cNvPr id="12" name="Text 10"/>
+          <p:cNvPr id="14" name="Text 11"/>
           <p:cNvSpPr/>
           <p:nvPr/>
         </p:nvSpPr>
@@ -2766,7 +2829,7 @@
       </p:sp>
       <p:sp>
         <p:nvSpPr>
-          <p:cNvPr id="13" name="Text 11"/>
+          <p:cNvPr id="15" name="Text 12"/>
           <p:cNvSpPr/>
           <p:nvPr/>
         </p:nvSpPr>
@@ -3477,9 +3540,33 @@
           </a:p>
         </p:txBody>
       </p:sp>
-      <p:sp>
-        <p:nvSpPr>
-          <p:cNvPr id="14" name="Text 12"/>
+      <p:pic>
+        <p:nvPicPr>
+          <p:cNvPr id="14" name="Image 0" descr="C:/Users/gvera/Projects/FitManager_AI_Studio/data/pitch-logo.png">    </p:cNvPr>
+          <p:cNvPicPr>
+            <a:picLocks noChangeAspect="1"/>
+          </p:cNvPicPr>
+          <p:nvPr/>
+        </p:nvPicPr>
+        <p:blipFill>
+          <a:blip r:embed="rId1"/>
+          <a:stretch>
+            <a:fillRect/>
+          </a:stretch>
+        </p:blipFill>
+        <p:spPr>
+          <a:xfrm>
+            <a:off x="91440" y="4526280"/>
+            <a:ext cx="502920" cy="457200"/>
+          </a:xfrm>
+          <a:prstGeom prst="rect">
+            <a:avLst/>
+          </a:prstGeom>
+        </p:spPr>
+      </p:pic>
+      <p:sp>
+        <p:nvSpPr>
+          <p:cNvPr id="15" name="Text 12"/>
           <p:cNvSpPr/>
           <p:nvPr/>
         </p:nvSpPr>
@@ -4600,7 +4687,7 @@
         <p:spPr>
           <a:xfrm>
             <a:off x="457200" y="3474720"/>
-            <a:ext cx="8229600" cy="548640"/>
+            <a:ext cx="8229600" cy="502920"/>
           </a:xfrm>
           <a:prstGeom prst="rect">
             <a:avLst/>
@@ -4620,7 +4707,7 @@
         <p:spPr>
           <a:xfrm>
             <a:off x="457200" y="3474720"/>
-            <a:ext cx="54864" cy="548640"/>
+            <a:ext cx="54864" cy="502920"/>
           </a:xfrm>
           <a:prstGeom prst="rect">
             <a:avLst/>
@@ -4639,8 +4726,8 @@
         </p:nvSpPr>
         <p:spPr>
           <a:xfrm>
-            <a:off x="914400" y="3493008"/>
-            <a:ext cx="914400" cy="502920"/>
+            <a:off x="731520" y="3493008"/>
+            <a:ext cx="1188720" cy="457200"/>
           </a:xfrm>
           <a:prstGeom prst="rect">
             <a:avLst/>
@@ -4656,7 +4743,7 @@
               <a:buNone/>
             </a:pPr>
             <a:r>
-              <a:rPr lang="en-US" sz="2200" b="1" dirty="0">
+              <a:rPr lang="en-US" sz="1800" b="1" dirty="0">
                 <a:solidFill>
                   <a:srgbClr val="14B8A6"/>
                 </a:solidFill>
@@ -4666,7 +4753,7 @@
               </a:rPr>
               <a:t>18</a:t>
             </a:r>
-            <a:endParaRPr lang="en-US" sz="2200" dirty="0"/>
+            <a:endParaRPr lang="en-US" sz="1800" dirty="0"/>
           </a:p>
         </p:txBody>
       </p:sp>
@@ -4678,8 +4765,8 @@
         </p:nvSpPr>
         <p:spPr>
           <a:xfrm>
-            <a:off x="1828800" y="3493008"/>
-            <a:ext cx="1645920" cy="502920"/>
+            <a:off x="1920240" y="3493008"/>
+            <a:ext cx="1463040" cy="457200"/>
           </a:xfrm>
           <a:prstGeom prst="rect">
             <a:avLst/>
@@ -4717,8 +4804,8 @@
         </p:nvSpPr>
         <p:spPr>
           <a:xfrm>
-            <a:off x="3657600" y="3493008"/>
-            <a:ext cx="914400" cy="502920"/>
+            <a:off x="3474720" y="3493008"/>
+            <a:ext cx="1188720" cy="457200"/>
           </a:xfrm>
           <a:prstGeom prst="rect">
             <a:avLst/>
@@ -4734,7 +4821,7 @@
               <a:buNone/>
             </a:pPr>
             <a:r>
-              <a:rPr lang="en-US" sz="2200" b="1" dirty="0">
+              <a:rPr lang="en-US" sz="1800" b="1" dirty="0">
                 <a:solidFill>
                   <a:srgbClr val="14B8A6"/>
                 </a:solidFill>
@@ -4744,7 +4831,7 @@
               </a:rPr>
               <a:t>35+</a:t>
             </a:r>
-            <a:endParaRPr lang="en-US" sz="2200" dirty="0"/>
+            <a:endParaRPr lang="en-US" sz="1800" dirty="0"/>
           </a:p>
         </p:txBody>
       </p:sp>
@@ -4756,8 +4843,8 @@
         </p:nvSpPr>
         <p:spPr>
           <a:xfrm>
-            <a:off x="4572000" y="3493008"/>
-            <a:ext cx="1645920" cy="502920"/>
+            <a:off x="4663440" y="3493008"/>
+            <a:ext cx="1463040" cy="457200"/>
           </a:xfrm>
           <a:prstGeom prst="rect">
             <a:avLst/>
@@ -4795,8 +4882,8 @@
         </p:nvSpPr>
         <p:spPr>
           <a:xfrm>
-            <a:off x="6400800" y="3493008"/>
-            <a:ext cx="914400" cy="502920"/>
+            <a:off x="6217920" y="3493008"/>
+            <a:ext cx="1188720" cy="457200"/>
           </a:xfrm>
           <a:prstGeom prst="rect">
             <a:avLst/>
@@ -4812,7 +4899,7 @@
               <a:buNone/>
             </a:pPr>
             <a:r>
-              <a:rPr lang="en-US" sz="2200" b="1" dirty="0">
+              <a:rPr lang="en-US" sz="1800" b="1" dirty="0">
                 <a:solidFill>
                   <a:srgbClr val="14B8A6"/>
                 </a:solidFill>
@@ -4820,9 +4907,9 @@
                 <a:ea typeface="Georgia" pitchFamily="34" charset="-122"/>
                 <a:cs typeface="Georgia" pitchFamily="34" charset="-120"/>
               </a:rPr>
-              <a:t>~5.600</a:t>
-            </a:r>
-            <a:endParaRPr lang="en-US" sz="2200" dirty="0"/>
+              <a:t>5.600</a:t>
+            </a:r>
+            <a:endParaRPr lang="en-US" sz="1800" dirty="0"/>
           </a:p>
         </p:txBody>
       </p:sp>
@@ -4834,8 +4921,8 @@
         </p:nvSpPr>
         <p:spPr>
           <a:xfrm>
-            <a:off x="7315200" y="3493008"/>
-            <a:ext cx="1645920" cy="502920"/>
+            <a:off x="7406640" y="3493008"/>
+            <a:ext cx="1463040" cy="457200"/>
           </a:xfrm>
           <a:prstGeom prst="rect">
             <a:avLst/>
@@ -4873,8 +4960,8 @@
         </p:nvSpPr>
         <p:spPr>
           <a:xfrm>
-            <a:off x="731520" y="4160520"/>
-            <a:ext cx="7680960" cy="365760"/>
+            <a:off x="457200" y="4069080"/>
+            <a:ext cx="8229600" cy="320040"/>
           </a:xfrm>
           <a:prstGeom prst="rect">
             <a:avLst/>
@@ -4890,7 +4977,7 @@
               <a:buNone/>
             </a:pPr>
             <a:r>
-              <a:rPr lang="en-US" sz="1000" i="1" dirty="0">
+              <a:rPr lang="en-US" sz="900" i="1" dirty="0">
                 <a:solidFill>
                   <a:srgbClr val="475569"/>
                 </a:solidFill>
@@ -4898,35 +4985,39 @@
                 <a:ea typeface="Calibri" pitchFamily="34" charset="-122"/>
                 <a:cs typeface="Calibri" pitchFamily="34" charset="-120"/>
               </a:rPr>
-              <a:t>Fonti: Schoenfeld, Israetel (RP), NSCA (Haff &amp; Triplett), Contreras, Helms, Bompa, LARN 2014 (SINU), CREA 2018, OMS/ACSM/AHA</a:t>
-            </a:r>
-            <a:endParaRPr lang="en-US" sz="1000" dirty="0"/>
-          </a:p>
-        </p:txBody>
-      </p:sp>
-      <p:sp>
-        <p:nvSpPr>
-          <p:cNvPr id="39" name="Shape 37"/>
-          <p:cNvSpPr/>
-          <p:nvPr/>
-        </p:nvSpPr>
-        <p:spPr>
-          <a:xfrm>
-            <a:off x="5120640" y="3931920"/>
-            <a:ext cx="3611880" cy="777240"/>
-          </a:xfrm>
-          <a:prstGeom prst="rect">
-            <a:avLst/>
-          </a:prstGeom>
-          <a:solidFill>
-            <a:srgbClr val="0F172A"/>
-          </a:solidFill>
-          <a:ln/>
-        </p:spPr>
-      </p:sp>
-      <p:sp>
-        <p:nvSpPr>
-          <p:cNvPr id="40" name="Text 38"/>
+              <a:t>Fonti: Schoenfeld, Israetel (RP), NSCA (Haff &amp; Triplett), Contreras, Helms, Bompa, LARN 2014, CREA 2018, OMS/ACSM/AHA</a:t>
+            </a:r>
+            <a:endParaRPr lang="en-US" sz="900" dirty="0"/>
+          </a:p>
+        </p:txBody>
+      </p:sp>
+      <p:pic>
+        <p:nvPicPr>
+          <p:cNvPr id="39" name="Image 0" descr="C:/Users/gvera/Projects/FitManager_AI_Studio/data/pitch-logo.png">    </p:cNvPr>
+          <p:cNvPicPr>
+            <a:picLocks noChangeAspect="1"/>
+          </p:cNvPicPr>
+          <p:nvPr/>
+        </p:nvPicPr>
+        <p:blipFill>
+          <a:blip r:embed="rId1"/>
+          <a:stretch>
+            <a:fillRect/>
+          </a:stretch>
+        </p:blipFill>
+        <p:spPr>
+          <a:xfrm>
+            <a:off x="91440" y="4526280"/>
+            <a:ext cx="502920" cy="457200"/>
+          </a:xfrm>
+          <a:prstGeom prst="rect">
+            <a:avLst/>
+          </a:prstGeom>
+        </p:spPr>
+      </p:pic>
+      <p:sp>
+        <p:nvSpPr>
+          <p:cNvPr id="40" name="Text 37"/>
           <p:cNvSpPr/>
           <p:nvPr/>
         </p:nvSpPr>
@@ -5751,9 +5842,33 @@
           </a:p>
         </p:txBody>
       </p:sp>
-      <p:sp>
-        <p:nvSpPr>
-          <p:cNvPr id="23" name="Text 21"/>
+      <p:pic>
+        <p:nvPicPr>
+          <p:cNvPr id="23" name="Image 0" descr="C:/Users/gvera/Projects/FitManager_AI_Studio/data/pitch-logo.png">    </p:cNvPr>
+          <p:cNvPicPr>
+            <a:picLocks noChangeAspect="1"/>
+          </p:cNvPicPr>
+          <p:nvPr/>
+        </p:nvPicPr>
+        <p:blipFill>
+          <a:blip r:embed="rId1"/>
+          <a:stretch>
+            <a:fillRect/>
+          </a:stretch>
+        </p:blipFill>
+        <p:spPr>
+          <a:xfrm>
+            <a:off x="91440" y="4526280"/>
+            <a:ext cx="502920" cy="457200"/>
+          </a:xfrm>
+          <a:prstGeom prst="rect">
+            <a:avLst/>
+          </a:prstGeom>
+        </p:spPr>
+      </p:pic>
+      <p:sp>
+        <p:nvSpPr>
+          <p:cNvPr id="24" name="Text 21"/>
           <p:cNvSpPr/>
           <p:nvPr/>
         </p:nvSpPr>
@@ -9516,9 +9631,33 @@
           </a:graphicData>
         </a:graphic>
       </p:graphicFrame>
-      <p:sp>
-        <p:nvSpPr>
-          <p:cNvPr id="4" name="Text 1"/>
+      <p:pic>
+        <p:nvPicPr>
+          <p:cNvPr id="4" name="Image 0" descr="C:/Users/gvera/Projects/FitManager_AI_Studio/data/pitch-logo.png">    </p:cNvPr>
+          <p:cNvPicPr>
+            <a:picLocks noChangeAspect="1"/>
+          </p:cNvPicPr>
+          <p:nvPr/>
+        </p:nvPicPr>
+        <p:blipFill>
+          <a:blip r:embed="rId1"/>
+          <a:stretch>
+            <a:fillRect/>
+          </a:stretch>
+        </p:blipFill>
+        <p:spPr>
+          <a:xfrm>
+            <a:off x="91440" y="4526280"/>
+            <a:ext cx="502920" cy="457200"/>
+          </a:xfrm>
+          <a:prstGeom prst="rect">
+            <a:avLst/>
+          </a:prstGeom>
+        </p:spPr>
+      </p:pic>
+      <p:sp>
+        <p:nvSpPr>
+          <p:cNvPr id="5" name="Text 1"/>
           <p:cNvSpPr/>
           <p:nvPr/>
         </p:nvSpPr>
@@ -11122,8 +11261,8 @@
         </p:nvSpPr>
         <p:spPr>
           <a:xfrm>
-            <a:off x="914400" y="1371600"/>
-            <a:ext cx="3291840" cy="502920"/>
+            <a:off x="914400" y="1325880"/>
+            <a:ext cx="3291840" cy="457200"/>
           </a:xfrm>
           <a:prstGeom prst="rect">
             <a:avLst/>
@@ -11139,7 +11278,7 @@
               <a:buNone/>
             </a:pPr>
             <a:r>
-              <a:rPr lang="en-US" sz="3600" b="1" dirty="0">
+              <a:rPr lang="en-US" sz="2800" b="1" dirty="0">
                 <a:solidFill>
                   <a:srgbClr val="0D9488"/>
                 </a:solidFill>
@@ -11149,7 +11288,7 @@
               </a:rPr>
               <a:t>EUR 149 - 249</a:t>
             </a:r>
-            <a:endParaRPr lang="en-US" sz="3600" dirty="0"/>
+            <a:endParaRPr lang="en-US" sz="2800" dirty="0"/>
           </a:p>
         </p:txBody>
       </p:sp>
@@ -11161,7 +11300,7 @@
         </p:nvSpPr>
         <p:spPr>
           <a:xfrm>
-            <a:off x="914400" y="1874520"/>
+            <a:off x="914400" y="1783080"/>
             <a:ext cx="3291840" cy="274320"/>
           </a:xfrm>
           <a:prstGeom prst="rect">
@@ -11178,7 +11317,7 @@
               <a:buNone/>
             </a:pPr>
             <a:r>
-              <a:rPr lang="en-US" sz="1400" b="1" dirty="0">
+              <a:rPr lang="en-US" sz="1300" b="1" dirty="0">
                 <a:solidFill>
                   <a:srgbClr val="1E293B"/>
                 </a:solidFill>
@@ -11188,7 +11327,7 @@
               </a:rPr>
               <a:t>Una tantum. Per sempre.</a:t>
             </a:r>
-            <a:endParaRPr lang="en-US" sz="1400" dirty="0"/>
+            <a:endParaRPr lang="en-US" sz="1300" dirty="0"/>
           </a:p>
         </p:txBody>
       </p:sp>
@@ -11200,8 +11339,8 @@
         </p:nvSpPr>
         <p:spPr>
           <a:xfrm>
-            <a:off x="1097280" y="2194560"/>
-            <a:ext cx="2926080" cy="1463040"/>
+            <a:off x="1097280" y="2103120"/>
+            <a:ext cx="2926080" cy="1554480"/>
           </a:xfrm>
           <a:prstGeom prst="rect">
             <a:avLst/>
@@ -11413,8 +11552,8 @@
         </p:nvSpPr>
         <p:spPr>
           <a:xfrm>
-            <a:off x="4937760" y="1371600"/>
-            <a:ext cx="3291840" cy="502920"/>
+            <a:off x="4937760" y="1325880"/>
+            <a:ext cx="3291840" cy="457200"/>
           </a:xfrm>
           <a:prstGeom prst="rect">
             <a:avLst/>
@@ -11430,7 +11569,7 @@
               <a:buNone/>
             </a:pPr>
             <a:r>
-              <a:rPr lang="en-US" sz="3000" b="1" dirty="0">
+              <a:rPr lang="en-US" sz="2600" b="1" dirty="0">
                 <a:solidFill>
                   <a:srgbClr val="F97066"/>
                 </a:solidFill>
@@ -11440,7 +11579,7 @@
               </a:rPr>
               <a:t>EUR 468 - 696</a:t>
             </a:r>
-            <a:endParaRPr lang="en-US" sz="3000" dirty="0"/>
+            <a:endParaRPr lang="en-US" sz="2600" dirty="0"/>
           </a:p>
         </p:txBody>
       </p:sp>
@@ -11452,7 +11591,7 @@
         </p:nvSpPr>
         <p:spPr>
           <a:xfrm>
-            <a:off x="4937760" y="1874520"/>
+            <a:off x="4937760" y="1783080"/>
             <a:ext cx="3291840" cy="274320"/>
           </a:xfrm>
           <a:prstGeom prst="rect">
@@ -11469,7 +11608,7 @@
               <a:buNone/>
             </a:pPr>
             <a:r>
-              <a:rPr lang="en-US" sz="1400" b="1" dirty="0">
+              <a:rPr lang="en-US" sz="1300" b="1" dirty="0">
                 <a:solidFill>
                   <a:srgbClr val="1E293B"/>
                 </a:solidFill>
@@ -11479,7 +11618,7 @@
               </a:rPr>
               <a:t>All'anno. Ogni anno. Per sempre.</a:t>
             </a:r>
-            <a:endParaRPr lang="en-US" sz="1400" dirty="0"/>
+            <a:endParaRPr lang="en-US" sz="1300" dirty="0"/>
           </a:p>
         </p:txBody>
       </p:sp>
@@ -11491,8 +11630,8 @@
         </p:nvSpPr>
         <p:spPr>
           <a:xfrm>
-            <a:off x="5120640" y="2194560"/>
-            <a:ext cx="2926080" cy="1463040"/>
+            <a:off x="5120640" y="2103120"/>
+            <a:ext cx="2926080" cy="1554480"/>
           </a:xfrm>
           <a:prstGeom prst="rect">
             <a:avLst/>
@@ -11758,9 +11897,33 @@
           </a:p>
         </p:txBody>
       </p:sp>
-      <p:sp>
-        <p:nvSpPr>
-          <p:cNvPr id="19" name="Text 17"/>
+      <p:pic>
+        <p:nvPicPr>
+          <p:cNvPr id="19" name="Image 0" descr="C:/Users/gvera/Projects/FitManager_AI_Studio/data/pitch-logo.png">    </p:cNvPr>
+          <p:cNvPicPr>
+            <a:picLocks noChangeAspect="1"/>
+          </p:cNvPicPr>
+          <p:nvPr/>
+        </p:nvPicPr>
+        <p:blipFill>
+          <a:blip r:embed="rId1"/>
+          <a:stretch>
+            <a:fillRect/>
+          </a:stretch>
+        </p:blipFill>
+        <p:spPr>
+          <a:xfrm>
+            <a:off x="91440" y="4526280"/>
+            <a:ext cx="502920" cy="457200"/>
+          </a:xfrm>
+          <a:prstGeom prst="rect">
+            <a:avLst/>
+          </a:prstGeom>
+        </p:spPr>
+      </p:pic>
+      <p:sp>
+        <p:nvSpPr>
+          <p:cNvPr id="20" name="Text 17"/>
           <p:cNvSpPr/>
           <p:nvPr/>
         </p:nvSpPr>
@@ -12772,9 +12935,33 @@
           </a:p>
         </p:txBody>
       </p:sp>
-      <p:sp>
-        <p:nvSpPr>
-          <p:cNvPr id="27" name="Text 25"/>
+      <p:pic>
+        <p:nvPicPr>
+          <p:cNvPr id="27" name="Image 0" descr="C:/Users/gvera/Projects/FitManager_AI_Studio/data/pitch-logo.png">    </p:cNvPr>
+          <p:cNvPicPr>
+            <a:picLocks noChangeAspect="1"/>
+          </p:cNvPicPr>
+          <p:nvPr/>
+        </p:nvPicPr>
+        <p:blipFill>
+          <a:blip r:embed="rId1"/>
+          <a:stretch>
+            <a:fillRect/>
+          </a:stretch>
+        </p:blipFill>
+        <p:spPr>
+          <a:xfrm>
+            <a:off x="91440" y="4526280"/>
+            <a:ext cx="502920" cy="457200"/>
+          </a:xfrm>
+          <a:prstGeom prst="rect">
+            <a:avLst/>
+          </a:prstGeom>
+        </p:spPr>
+      </p:pic>
+      <p:sp>
+        <p:nvSpPr>
+          <p:cNvPr id="28" name="Text 25"/>
           <p:cNvSpPr/>
           <p:nvPr/>
         </p:nvSpPr>
@@ -12871,8 +13058,8 @@
         </p:nvSpPr>
         <p:spPr>
           <a:xfrm>
-            <a:off x="731520" y="640080"/>
-            <a:ext cx="7680960" cy="1828800"/>
+            <a:off x="731520" y="822960"/>
+            <a:ext cx="7680960" cy="1645920"/>
           </a:xfrm>
           <a:prstGeom prst="rect">
             <a:avLst/>
@@ -12886,12 +13073,12 @@
           <a:p>
             <a:pPr indent="0" marL="0">
               <a:lnSpc>
-                <a:spcPct val="120000"/>
+                <a:spcPct val="130000"/>
               </a:lnSpc>
               <a:buNone/>
             </a:pPr>
             <a:r>
-              <a:rPr lang="en-US" sz="4400" b="1" dirty="0">
+              <a:rPr lang="en-US" sz="3600" b="1" dirty="0">
                 <a:solidFill>
                   <a:srgbClr val="FFFFFF"/>
                 </a:solidFill>
@@ -12901,17 +13088,17 @@
               </a:rPr>
               <a:t>Il tuo studio.</a:t>
             </a:r>
-            <a:endParaRPr lang="en-US" sz="4400" dirty="0"/>
+            <a:endParaRPr lang="en-US" sz="3600" dirty="0"/>
           </a:p>
           <a:p>
             <a:pPr indent="0" marL="0">
               <a:lnSpc>
-                <a:spcPct val="120000"/>
+                <a:spcPct val="130000"/>
               </a:lnSpc>
               <a:buNone/>
             </a:pPr>
             <a:r>
-              <a:rPr lang="en-US" sz="4400" b="1" dirty="0">
+              <a:rPr lang="en-US" sz="3600" b="1" dirty="0">
                 <a:solidFill>
                   <a:srgbClr val="FFFFFF"/>
                 </a:solidFill>
@@ -12921,17 +13108,17 @@
               </a:rPr>
               <a:t>I tuoi dati.</a:t>
             </a:r>
-            <a:endParaRPr lang="en-US" sz="4400" dirty="0"/>
+            <a:endParaRPr lang="en-US" sz="3600" dirty="0"/>
           </a:p>
           <a:p>
             <a:pPr indent="0" marL="0">
               <a:lnSpc>
-                <a:spcPct val="120000"/>
+                <a:spcPct val="130000"/>
               </a:lnSpc>
               <a:buNone/>
             </a:pPr>
             <a:r>
-              <a:rPr lang="en-US" sz="4400" b="1" dirty="0">
+              <a:rPr lang="en-US" sz="3600" b="1" dirty="0">
                 <a:solidFill>
                   <a:srgbClr val="FFFFFF"/>
                 </a:solidFill>
@@ -12941,7 +13128,7 @@
               </a:rPr>
               <a:t>La tua scienza.</a:t>
             </a:r>
-            <a:endParaRPr lang="en-US" sz="4400" dirty="0"/>
+            <a:endParaRPr lang="en-US" sz="3600" dirty="0"/>
           </a:p>
         </p:txBody>
       </p:sp>
@@ -12953,8 +13140,8 @@
         </p:nvSpPr>
         <p:spPr>
           <a:xfrm>
-            <a:off x="731520" y="2560320"/>
-            <a:ext cx="7680960" cy="457200"/>
+            <a:off x="731520" y="2606040"/>
+            <a:ext cx="7680960" cy="411480"/>
           </a:xfrm>
           <a:prstGeom prst="rect">
             <a:avLst/>
@@ -12970,7 +13157,7 @@
               <a:buNone/>
             </a:pPr>
             <a:r>
-              <a:rPr lang="en-US" sz="2400" dirty="0">
+              <a:rPr lang="en-US" sz="2000" dirty="0">
                 <a:solidFill>
                   <a:srgbClr val="14B8A6"/>
                 </a:solidFill>
@@ -12980,7 +13167,7 @@
               </a:rPr>
               <a:t>FitManager Studio+</a:t>
             </a:r>
-            <a:endParaRPr lang="en-US" sz="2400" dirty="0"/>
+            <a:endParaRPr lang="en-US" sz="2000" dirty="0"/>
           </a:p>
         </p:txBody>
       </p:sp>
@@ -12992,7 +13179,7 @@
         </p:nvSpPr>
         <p:spPr>
           <a:xfrm>
-            <a:off x="731520" y="3291840"/>
+            <a:off x="731520" y="3200400"/>
             <a:ext cx="3291840" cy="502920"/>
           </a:xfrm>
           <a:prstGeom prst="rect">
@@ -13012,7 +13199,7 @@
         </p:nvSpPr>
         <p:spPr>
           <a:xfrm>
-            <a:off x="731520" y="3291840"/>
+            <a:off x="731520" y="3200400"/>
             <a:ext cx="3291840" cy="502920"/>
           </a:xfrm>
           <a:prstGeom prst="rect">
@@ -13051,8 +13238,8 @@
         </p:nvSpPr>
         <p:spPr>
           <a:xfrm>
-            <a:off x="731520" y="3931920"/>
-            <a:ext cx="7680960" cy="320040"/>
+            <a:off x="731520" y="3794760"/>
+            <a:ext cx="7680960" cy="274320"/>
           </a:xfrm>
           <a:prstGeom prst="rect">
             <a:avLst/>
@@ -13068,7 +13255,7 @@
               <a:buNone/>
             </a:pPr>
             <a:r>
-              <a:rPr lang="en-US" sz="1400" dirty="0">
+              <a:rPr lang="en-US" sz="1300" dirty="0">
                 <a:solidFill>
                   <a:srgbClr val="64748B"/>
                 </a:solidFill>
@@ -13078,7 +13265,7 @@
               </a:rPr>
               <a:t>info@fitmanager.studio</a:t>
             </a:r>
-            <a:endParaRPr lang="en-US" sz="1400" dirty="0"/>
+            <a:endParaRPr lang="en-US" sz="1300" dirty="0"/>
           </a:p>
         </p:txBody>
       </p:sp>
@@ -13755,9 +13942,33 @@
           </a:p>
         </p:txBody>
       </p:sp>
-      <p:sp>
-        <p:nvSpPr>
-          <p:cNvPr id="15" name="Text 13"/>
+      <p:pic>
+        <p:nvPicPr>
+          <p:cNvPr id="15" name="Image 0" descr="C:/Users/gvera/Projects/FitManager_AI_Studio/data/pitch-logo.png">    </p:cNvPr>
+          <p:cNvPicPr>
+            <a:picLocks noChangeAspect="1"/>
+          </p:cNvPicPr>
+          <p:nvPr/>
+        </p:nvPicPr>
+        <p:blipFill>
+          <a:blip r:embed="rId1"/>
+          <a:stretch>
+            <a:fillRect/>
+          </a:stretch>
+        </p:blipFill>
+        <p:spPr>
+          <a:xfrm>
+            <a:off x="91440" y="4526280"/>
+            <a:ext cx="502920" cy="457200"/>
+          </a:xfrm>
+          <a:prstGeom prst="rect">
+            <a:avLst/>
+          </a:prstGeom>
+        </p:spPr>
+      </p:pic>
+      <p:sp>
+        <p:nvSpPr>
+          <p:cNvPr id="16" name="Text 13"/>
           <p:cNvSpPr/>
           <p:nvPr/>
         </p:nvSpPr>
@@ -14632,9 +14843,33 @@
           </a:p>
         </p:txBody>
       </p:sp>
-      <p:sp>
-        <p:nvSpPr>
-          <p:cNvPr id="29" name="Text 27"/>
+      <p:pic>
+        <p:nvPicPr>
+          <p:cNvPr id="29" name="Image 0" descr="C:/Users/gvera/Projects/FitManager_AI_Studio/data/pitch-logo.png">    </p:cNvPr>
+          <p:cNvPicPr>
+            <a:picLocks noChangeAspect="1"/>
+          </p:cNvPicPr>
+          <p:nvPr/>
+        </p:nvPicPr>
+        <p:blipFill>
+          <a:blip r:embed="rId1"/>
+          <a:stretch>
+            <a:fillRect/>
+          </a:stretch>
+        </p:blipFill>
+        <p:spPr>
+          <a:xfrm>
+            <a:off x="91440" y="4526280"/>
+            <a:ext cx="502920" cy="457200"/>
+          </a:xfrm>
+          <a:prstGeom prst="rect">
+            <a:avLst/>
+          </a:prstGeom>
+        </p:spPr>
+      </p:pic>
+      <p:sp>
+        <p:nvSpPr>
+          <p:cNvPr id="30" name="Text 27"/>
           <p:cNvSpPr/>
           <p:nvPr/>
         </p:nvSpPr>
@@ -14852,9 +15087,33 @@
           </a:prstGeom>
         </p:spPr>
       </p:pic>
-      <p:sp>
-        <p:nvSpPr>
-          <p:cNvPr id="7" name="Text 4"/>
+      <p:pic>
+        <p:nvPicPr>
+          <p:cNvPr id="7" name="Image 1" descr="C:/Users/gvera/Projects/FitManager_AI_Studio/data/pitch-logo.png">    </p:cNvPr>
+          <p:cNvPicPr>
+            <a:picLocks noChangeAspect="1"/>
+          </p:cNvPicPr>
+          <p:nvPr/>
+        </p:nvPicPr>
+        <p:blipFill>
+          <a:blip r:embed="rId2"/>
+          <a:stretch>
+            <a:fillRect/>
+          </a:stretch>
+        </p:blipFill>
+        <p:spPr>
+          <a:xfrm>
+            <a:off x="91440" y="4526280"/>
+            <a:ext cx="502920" cy="457200"/>
+          </a:xfrm>
+          <a:prstGeom prst="rect">
+            <a:avLst/>
+          </a:prstGeom>
+        </p:spPr>
+      </p:pic>
+      <p:sp>
+        <p:nvSpPr>
+          <p:cNvPr id="8" name="Text 4"/>
           <p:cNvSpPr/>
           <p:nvPr/>
         </p:nvSpPr>
@@ -15151,9 +15410,33 @@
           </a:p>
         </p:txBody>
       </p:sp>
-      <p:sp>
-        <p:nvSpPr>
-          <p:cNvPr id="10" name="Text 7"/>
+      <p:pic>
+        <p:nvPicPr>
+          <p:cNvPr id="10" name="Image 1" descr="C:/Users/gvera/Projects/FitManager_AI_Studio/data/pitch-logo.png">    </p:cNvPr>
+          <p:cNvPicPr>
+            <a:picLocks noChangeAspect="1"/>
+          </p:cNvPicPr>
+          <p:nvPr/>
+        </p:nvPicPr>
+        <p:blipFill>
+          <a:blip r:embed="rId2"/>
+          <a:stretch>
+            <a:fillRect/>
+          </a:stretch>
+        </p:blipFill>
+        <p:spPr>
+          <a:xfrm>
+            <a:off x="91440" y="4526280"/>
+            <a:ext cx="502920" cy="457200"/>
+          </a:xfrm>
+          <a:prstGeom prst="rect">
+            <a:avLst/>
+          </a:prstGeom>
+        </p:spPr>
+      </p:pic>
+      <p:sp>
+        <p:nvSpPr>
+          <p:cNvPr id="11" name="Text 7"/>
           <p:cNvSpPr/>
           <p:nvPr/>
         </p:nvSpPr>
@@ -15371,9 +15654,33 @@
           </a:prstGeom>
         </p:spPr>
       </p:pic>
-      <p:sp>
-        <p:nvSpPr>
-          <p:cNvPr id="7" name="Text 4"/>
+      <p:pic>
+        <p:nvPicPr>
+          <p:cNvPr id="7" name="Image 1" descr="C:/Users/gvera/Projects/FitManager_AI_Studio/data/pitch-logo.png">    </p:cNvPr>
+          <p:cNvPicPr>
+            <a:picLocks noChangeAspect="1"/>
+          </p:cNvPicPr>
+          <p:nvPr/>
+        </p:nvPicPr>
+        <p:blipFill>
+          <a:blip r:embed="rId2"/>
+          <a:stretch>
+            <a:fillRect/>
+          </a:stretch>
+        </p:blipFill>
+        <p:spPr>
+          <a:xfrm>
+            <a:off x="91440" y="4526280"/>
+            <a:ext cx="502920" cy="457200"/>
+          </a:xfrm>
+          <a:prstGeom prst="rect">
+            <a:avLst/>
+          </a:prstGeom>
+        </p:spPr>
+      </p:pic>
+      <p:sp>
+        <p:nvSpPr>
+          <p:cNvPr id="8" name="Text 4"/>
           <p:cNvSpPr/>
           <p:nvPr/>
         </p:nvSpPr>
@@ -15591,9 +15898,33 @@
           </a:prstGeom>
         </p:spPr>
       </p:pic>
-      <p:sp>
-        <p:nvSpPr>
-          <p:cNvPr id="7" name="Text 4"/>
+      <p:pic>
+        <p:nvPicPr>
+          <p:cNvPr id="7" name="Image 1" descr="C:/Users/gvera/Projects/FitManager_AI_Studio/data/pitch-logo.png">    </p:cNvPr>
+          <p:cNvPicPr>
+            <a:picLocks noChangeAspect="1"/>
+          </p:cNvPicPr>
+          <p:nvPr/>
+        </p:nvPicPr>
+        <p:blipFill>
+          <a:blip r:embed="rId2"/>
+          <a:stretch>
+            <a:fillRect/>
+          </a:stretch>
+        </p:blipFill>
+        <p:spPr>
+          <a:xfrm>
+            <a:off x="91440" y="4526280"/>
+            <a:ext cx="502920" cy="457200"/>
+          </a:xfrm>
+          <a:prstGeom prst="rect">
+            <a:avLst/>
+          </a:prstGeom>
+        </p:spPr>
+      </p:pic>
+      <p:sp>
+        <p:nvSpPr>
+          <p:cNvPr id="8" name="Text 4"/>
           <p:cNvSpPr/>
           <p:nvPr/>
         </p:nvSpPr>
@@ -15811,9 +16142,33 @@
           </a:prstGeom>
         </p:spPr>
       </p:pic>
-      <p:sp>
-        <p:nvSpPr>
-          <p:cNvPr id="7" name="Text 4"/>
+      <p:pic>
+        <p:nvPicPr>
+          <p:cNvPr id="7" name="Image 1" descr="C:/Users/gvera/Projects/FitManager_AI_Studio/data/pitch-logo.png">    </p:cNvPr>
+          <p:cNvPicPr>
+            <a:picLocks noChangeAspect="1"/>
+          </p:cNvPicPr>
+          <p:nvPr/>
+        </p:nvPicPr>
+        <p:blipFill>
+          <a:blip r:embed="rId2"/>
+          <a:stretch>
+            <a:fillRect/>
+          </a:stretch>
+        </p:blipFill>
+        <p:spPr>
+          <a:xfrm>
+            <a:off x="91440" y="4526280"/>
+            <a:ext cx="502920" cy="457200"/>
+          </a:xfrm>
+          <a:prstGeom prst="rect">
+            <a:avLst/>
+          </a:prstGeom>
+        </p:spPr>
+      </p:pic>
+      <p:sp>
+        <p:nvSpPr>
+          <p:cNvPr id="8" name="Text 4"/>
           <p:cNvSpPr/>
           <p:nvPr/>
         </p:nvSpPr>

</xml_diff>

<commit_message>
installer: v1.0.3 — fix 4 bug build pipeline + pitch deck update
- nutrition.db aggiunto allo staging release-data (mancava, ISCC falliva)
- seed_exercise_progressions.json aggiunto a .iss e .spec (usato dal codice)
- build-media query fix: JOIN esercizi per escludere 27 ID orfani
- EXPECTED_ACTIVE_COUNT 400→500, version bump 1.0.2→1.0.3
- pitch deck: rimosso logo watermark da slide interne

Co-Authored-By: Claude Opus 4.6 (1M context) <noreply@anthropic.com>
</commit_message>
<xml_diff>
--- a/data/FitManager_Pitch_Deck_v10.pptx
+++ b/data/FitManager_Pitch_Deck_v10.pptx
@@ -3540,33 +3540,9 @@
           </a:p>
         </p:txBody>
       </p:sp>
-      <p:pic>
-        <p:nvPicPr>
-          <p:cNvPr id="14" name="Image 0" descr="C:/Users/gvera/Projects/FitManager_AI_Studio/data/pitch-logo.png">    </p:cNvPr>
-          <p:cNvPicPr>
-            <a:picLocks noChangeAspect="1"/>
-          </p:cNvPicPr>
-          <p:nvPr/>
-        </p:nvPicPr>
-        <p:blipFill>
-          <a:blip r:embed="rId1"/>
-          <a:stretch>
-            <a:fillRect/>
-          </a:stretch>
-        </p:blipFill>
-        <p:spPr>
-          <a:xfrm>
-            <a:off x="91440" y="4526280"/>
-            <a:ext cx="502920" cy="457200"/>
-          </a:xfrm>
-          <a:prstGeom prst="rect">
-            <a:avLst/>
-          </a:prstGeom>
-        </p:spPr>
-      </p:pic>
-      <p:sp>
-        <p:nvSpPr>
-          <p:cNvPr id="15" name="Text 12"/>
+      <p:sp>
+        <p:nvSpPr>
+          <p:cNvPr id="14" name="Text 12"/>
           <p:cNvSpPr/>
           <p:nvPr/>
         </p:nvSpPr>
@@ -4991,33 +4967,9 @@
           </a:p>
         </p:txBody>
       </p:sp>
-      <p:pic>
-        <p:nvPicPr>
-          <p:cNvPr id="39" name="Image 0" descr="C:/Users/gvera/Projects/FitManager_AI_Studio/data/pitch-logo.png">    </p:cNvPr>
-          <p:cNvPicPr>
-            <a:picLocks noChangeAspect="1"/>
-          </p:cNvPicPr>
-          <p:nvPr/>
-        </p:nvPicPr>
-        <p:blipFill>
-          <a:blip r:embed="rId1"/>
-          <a:stretch>
-            <a:fillRect/>
-          </a:stretch>
-        </p:blipFill>
-        <p:spPr>
-          <a:xfrm>
-            <a:off x="91440" y="4526280"/>
-            <a:ext cx="502920" cy="457200"/>
-          </a:xfrm>
-          <a:prstGeom prst="rect">
-            <a:avLst/>
-          </a:prstGeom>
-        </p:spPr>
-      </p:pic>
-      <p:sp>
-        <p:nvSpPr>
-          <p:cNvPr id="40" name="Text 37"/>
+      <p:sp>
+        <p:nvSpPr>
+          <p:cNvPr id="39" name="Text 37"/>
           <p:cNvSpPr/>
           <p:nvPr/>
         </p:nvSpPr>
@@ -5842,33 +5794,9 @@
           </a:p>
         </p:txBody>
       </p:sp>
-      <p:pic>
-        <p:nvPicPr>
-          <p:cNvPr id="23" name="Image 0" descr="C:/Users/gvera/Projects/FitManager_AI_Studio/data/pitch-logo.png">    </p:cNvPr>
-          <p:cNvPicPr>
-            <a:picLocks noChangeAspect="1"/>
-          </p:cNvPicPr>
-          <p:nvPr/>
-        </p:nvPicPr>
-        <p:blipFill>
-          <a:blip r:embed="rId1"/>
-          <a:stretch>
-            <a:fillRect/>
-          </a:stretch>
-        </p:blipFill>
-        <p:spPr>
-          <a:xfrm>
-            <a:off x="91440" y="4526280"/>
-            <a:ext cx="502920" cy="457200"/>
-          </a:xfrm>
-          <a:prstGeom prst="rect">
-            <a:avLst/>
-          </a:prstGeom>
-        </p:spPr>
-      </p:pic>
-      <p:sp>
-        <p:nvSpPr>
-          <p:cNvPr id="24" name="Text 21"/>
+      <p:sp>
+        <p:nvSpPr>
+          <p:cNvPr id="23" name="Text 21"/>
           <p:cNvSpPr/>
           <p:nvPr/>
         </p:nvSpPr>
@@ -9631,33 +9559,9 @@
           </a:graphicData>
         </a:graphic>
       </p:graphicFrame>
-      <p:pic>
-        <p:nvPicPr>
-          <p:cNvPr id="4" name="Image 0" descr="C:/Users/gvera/Projects/FitManager_AI_Studio/data/pitch-logo.png">    </p:cNvPr>
-          <p:cNvPicPr>
-            <a:picLocks noChangeAspect="1"/>
-          </p:cNvPicPr>
-          <p:nvPr/>
-        </p:nvPicPr>
-        <p:blipFill>
-          <a:blip r:embed="rId1"/>
-          <a:stretch>
-            <a:fillRect/>
-          </a:stretch>
-        </p:blipFill>
-        <p:spPr>
-          <a:xfrm>
-            <a:off x="91440" y="4526280"/>
-            <a:ext cx="502920" cy="457200"/>
-          </a:xfrm>
-          <a:prstGeom prst="rect">
-            <a:avLst/>
-          </a:prstGeom>
-        </p:spPr>
-      </p:pic>
-      <p:sp>
-        <p:nvSpPr>
-          <p:cNvPr id="5" name="Text 1"/>
+      <p:sp>
+        <p:nvSpPr>
+          <p:cNvPr id="4" name="Text 1"/>
           <p:cNvSpPr/>
           <p:nvPr/>
         </p:nvSpPr>
@@ -11897,33 +11801,9 @@
           </a:p>
         </p:txBody>
       </p:sp>
-      <p:pic>
-        <p:nvPicPr>
-          <p:cNvPr id="19" name="Image 0" descr="C:/Users/gvera/Projects/FitManager_AI_Studio/data/pitch-logo.png">    </p:cNvPr>
-          <p:cNvPicPr>
-            <a:picLocks noChangeAspect="1"/>
-          </p:cNvPicPr>
-          <p:nvPr/>
-        </p:nvPicPr>
-        <p:blipFill>
-          <a:blip r:embed="rId1"/>
-          <a:stretch>
-            <a:fillRect/>
-          </a:stretch>
-        </p:blipFill>
-        <p:spPr>
-          <a:xfrm>
-            <a:off x="91440" y="4526280"/>
-            <a:ext cx="502920" cy="457200"/>
-          </a:xfrm>
-          <a:prstGeom prst="rect">
-            <a:avLst/>
-          </a:prstGeom>
-        </p:spPr>
-      </p:pic>
-      <p:sp>
-        <p:nvSpPr>
-          <p:cNvPr id="20" name="Text 17"/>
+      <p:sp>
+        <p:nvSpPr>
+          <p:cNvPr id="19" name="Text 17"/>
           <p:cNvSpPr/>
           <p:nvPr/>
         </p:nvSpPr>
@@ -12935,33 +12815,9 @@
           </a:p>
         </p:txBody>
       </p:sp>
-      <p:pic>
-        <p:nvPicPr>
-          <p:cNvPr id="27" name="Image 0" descr="C:/Users/gvera/Projects/FitManager_AI_Studio/data/pitch-logo.png">    </p:cNvPr>
-          <p:cNvPicPr>
-            <a:picLocks noChangeAspect="1"/>
-          </p:cNvPicPr>
-          <p:nvPr/>
-        </p:nvPicPr>
-        <p:blipFill>
-          <a:blip r:embed="rId1"/>
-          <a:stretch>
-            <a:fillRect/>
-          </a:stretch>
-        </p:blipFill>
-        <p:spPr>
-          <a:xfrm>
-            <a:off x="91440" y="4526280"/>
-            <a:ext cx="502920" cy="457200"/>
-          </a:xfrm>
-          <a:prstGeom prst="rect">
-            <a:avLst/>
-          </a:prstGeom>
-        </p:spPr>
-      </p:pic>
-      <p:sp>
-        <p:nvSpPr>
-          <p:cNvPr id="28" name="Text 25"/>
+      <p:sp>
+        <p:nvSpPr>
+          <p:cNvPr id="27" name="Text 25"/>
           <p:cNvSpPr/>
           <p:nvPr/>
         </p:nvSpPr>
@@ -13942,33 +13798,9 @@
           </a:p>
         </p:txBody>
       </p:sp>
-      <p:pic>
-        <p:nvPicPr>
-          <p:cNvPr id="15" name="Image 0" descr="C:/Users/gvera/Projects/FitManager_AI_Studio/data/pitch-logo.png">    </p:cNvPr>
-          <p:cNvPicPr>
-            <a:picLocks noChangeAspect="1"/>
-          </p:cNvPicPr>
-          <p:nvPr/>
-        </p:nvPicPr>
-        <p:blipFill>
-          <a:blip r:embed="rId1"/>
-          <a:stretch>
-            <a:fillRect/>
-          </a:stretch>
-        </p:blipFill>
-        <p:spPr>
-          <a:xfrm>
-            <a:off x="91440" y="4526280"/>
-            <a:ext cx="502920" cy="457200"/>
-          </a:xfrm>
-          <a:prstGeom prst="rect">
-            <a:avLst/>
-          </a:prstGeom>
-        </p:spPr>
-      </p:pic>
-      <p:sp>
-        <p:nvSpPr>
-          <p:cNvPr id="16" name="Text 13"/>
+      <p:sp>
+        <p:nvSpPr>
+          <p:cNvPr id="15" name="Text 13"/>
           <p:cNvSpPr/>
           <p:nvPr/>
         </p:nvSpPr>
@@ -14843,33 +14675,9 @@
           </a:p>
         </p:txBody>
       </p:sp>
-      <p:pic>
-        <p:nvPicPr>
-          <p:cNvPr id="29" name="Image 0" descr="C:/Users/gvera/Projects/FitManager_AI_Studio/data/pitch-logo.png">    </p:cNvPr>
-          <p:cNvPicPr>
-            <a:picLocks noChangeAspect="1"/>
-          </p:cNvPicPr>
-          <p:nvPr/>
-        </p:nvPicPr>
-        <p:blipFill>
-          <a:blip r:embed="rId1"/>
-          <a:stretch>
-            <a:fillRect/>
-          </a:stretch>
-        </p:blipFill>
-        <p:spPr>
-          <a:xfrm>
-            <a:off x="91440" y="4526280"/>
-            <a:ext cx="502920" cy="457200"/>
-          </a:xfrm>
-          <a:prstGeom prst="rect">
-            <a:avLst/>
-          </a:prstGeom>
-        </p:spPr>
-      </p:pic>
-      <p:sp>
-        <p:nvSpPr>
-          <p:cNvPr id="30" name="Text 27"/>
+      <p:sp>
+        <p:nvSpPr>
+          <p:cNvPr id="29" name="Text 27"/>
           <p:cNvSpPr/>
           <p:nvPr/>
         </p:nvSpPr>
@@ -15087,33 +14895,9 @@
           </a:prstGeom>
         </p:spPr>
       </p:pic>
-      <p:pic>
-        <p:nvPicPr>
-          <p:cNvPr id="7" name="Image 1" descr="C:/Users/gvera/Projects/FitManager_AI_Studio/data/pitch-logo.png">    </p:cNvPr>
-          <p:cNvPicPr>
-            <a:picLocks noChangeAspect="1"/>
-          </p:cNvPicPr>
-          <p:nvPr/>
-        </p:nvPicPr>
-        <p:blipFill>
-          <a:blip r:embed="rId2"/>
-          <a:stretch>
-            <a:fillRect/>
-          </a:stretch>
-        </p:blipFill>
-        <p:spPr>
-          <a:xfrm>
-            <a:off x="91440" y="4526280"/>
-            <a:ext cx="502920" cy="457200"/>
-          </a:xfrm>
-          <a:prstGeom prst="rect">
-            <a:avLst/>
-          </a:prstGeom>
-        </p:spPr>
-      </p:pic>
-      <p:sp>
-        <p:nvSpPr>
-          <p:cNvPr id="8" name="Text 4"/>
+      <p:sp>
+        <p:nvSpPr>
+          <p:cNvPr id="7" name="Text 4"/>
           <p:cNvSpPr/>
           <p:nvPr/>
         </p:nvSpPr>
@@ -15410,33 +15194,9 @@
           </a:p>
         </p:txBody>
       </p:sp>
-      <p:pic>
-        <p:nvPicPr>
-          <p:cNvPr id="10" name="Image 1" descr="C:/Users/gvera/Projects/FitManager_AI_Studio/data/pitch-logo.png">    </p:cNvPr>
-          <p:cNvPicPr>
-            <a:picLocks noChangeAspect="1"/>
-          </p:cNvPicPr>
-          <p:nvPr/>
-        </p:nvPicPr>
-        <p:blipFill>
-          <a:blip r:embed="rId2"/>
-          <a:stretch>
-            <a:fillRect/>
-          </a:stretch>
-        </p:blipFill>
-        <p:spPr>
-          <a:xfrm>
-            <a:off x="91440" y="4526280"/>
-            <a:ext cx="502920" cy="457200"/>
-          </a:xfrm>
-          <a:prstGeom prst="rect">
-            <a:avLst/>
-          </a:prstGeom>
-        </p:spPr>
-      </p:pic>
-      <p:sp>
-        <p:nvSpPr>
-          <p:cNvPr id="11" name="Text 7"/>
+      <p:sp>
+        <p:nvSpPr>
+          <p:cNvPr id="10" name="Text 7"/>
           <p:cNvSpPr/>
           <p:nvPr/>
         </p:nvSpPr>
@@ -15654,33 +15414,9 @@
           </a:prstGeom>
         </p:spPr>
       </p:pic>
-      <p:pic>
-        <p:nvPicPr>
-          <p:cNvPr id="7" name="Image 1" descr="C:/Users/gvera/Projects/FitManager_AI_Studio/data/pitch-logo.png">    </p:cNvPr>
-          <p:cNvPicPr>
-            <a:picLocks noChangeAspect="1"/>
-          </p:cNvPicPr>
-          <p:nvPr/>
-        </p:nvPicPr>
-        <p:blipFill>
-          <a:blip r:embed="rId2"/>
-          <a:stretch>
-            <a:fillRect/>
-          </a:stretch>
-        </p:blipFill>
-        <p:spPr>
-          <a:xfrm>
-            <a:off x="91440" y="4526280"/>
-            <a:ext cx="502920" cy="457200"/>
-          </a:xfrm>
-          <a:prstGeom prst="rect">
-            <a:avLst/>
-          </a:prstGeom>
-        </p:spPr>
-      </p:pic>
-      <p:sp>
-        <p:nvSpPr>
-          <p:cNvPr id="8" name="Text 4"/>
+      <p:sp>
+        <p:nvSpPr>
+          <p:cNvPr id="7" name="Text 4"/>
           <p:cNvSpPr/>
           <p:nvPr/>
         </p:nvSpPr>
@@ -15898,33 +15634,9 @@
           </a:prstGeom>
         </p:spPr>
       </p:pic>
-      <p:pic>
-        <p:nvPicPr>
-          <p:cNvPr id="7" name="Image 1" descr="C:/Users/gvera/Projects/FitManager_AI_Studio/data/pitch-logo.png">    </p:cNvPr>
-          <p:cNvPicPr>
-            <a:picLocks noChangeAspect="1"/>
-          </p:cNvPicPr>
-          <p:nvPr/>
-        </p:nvPicPr>
-        <p:blipFill>
-          <a:blip r:embed="rId2"/>
-          <a:stretch>
-            <a:fillRect/>
-          </a:stretch>
-        </p:blipFill>
-        <p:spPr>
-          <a:xfrm>
-            <a:off x="91440" y="4526280"/>
-            <a:ext cx="502920" cy="457200"/>
-          </a:xfrm>
-          <a:prstGeom prst="rect">
-            <a:avLst/>
-          </a:prstGeom>
-        </p:spPr>
-      </p:pic>
-      <p:sp>
-        <p:nvSpPr>
-          <p:cNvPr id="8" name="Text 4"/>
+      <p:sp>
+        <p:nvSpPr>
+          <p:cNvPr id="7" name="Text 4"/>
           <p:cNvSpPr/>
           <p:nvPr/>
         </p:nvSpPr>
@@ -16142,33 +15854,9 @@
           </a:prstGeom>
         </p:spPr>
       </p:pic>
-      <p:pic>
-        <p:nvPicPr>
-          <p:cNvPr id="7" name="Image 1" descr="C:/Users/gvera/Projects/FitManager_AI_Studio/data/pitch-logo.png">    </p:cNvPr>
-          <p:cNvPicPr>
-            <a:picLocks noChangeAspect="1"/>
-          </p:cNvPicPr>
-          <p:nvPr/>
-        </p:nvPicPr>
-        <p:blipFill>
-          <a:blip r:embed="rId2"/>
-          <a:stretch>
-            <a:fillRect/>
-          </a:stretch>
-        </p:blipFill>
-        <p:spPr>
-          <a:xfrm>
-            <a:off x="91440" y="4526280"/>
-            <a:ext cx="502920" cy="457200"/>
-          </a:xfrm>
-          <a:prstGeom prst="rect">
-            <a:avLst/>
-          </a:prstGeom>
-        </p:spPr>
-      </p:pic>
-      <p:sp>
-        <p:nvSpPr>
-          <p:cNvPr id="8" name="Text 4"/>
+      <p:sp>
+        <p:nvSpPr>
+          <p:cNvPr id="7" name="Text 4"/>
           <p:cNvSpPr/>
           <p:nvPr/>
         </p:nvSpPr>

</xml_diff>